<commit_message>
Text review: four spots where text touched lines or crowded
Every text line's position was measured in both versions (the browser's
own glyph rects for the HTML; PowerPoint's line bounds via COM for the
.pptx) and checked against every other line and every shape. No text
overlaps other text in either. Fixed what touched:
- Slide 7, premium chart: "saves about two-thirds" sat where the gap was
  too short for two lines, so the rising Flexi line clipped it; it now sits
  two-thirds of the way to the peak, centred between the lines at its own
  edges (series.py).
- Slide 7, future chart: "Adrian dies" and "Carmen 89" were 4 px apart;
  the last label is centred on its tick, overhanging the empty gutter.
- Slide 9: the goal band's dashed edge crossed "+14 points"; the label is
  centred on the arrow's run before the band.
- Slide 10: 83% sat 3 px under the header rule in PowerPoint; more room.

Co-Authored-By: Claude Opus 5.5 (1M context) <noreply@anthropic.com>
</commit_message>
<xml_diff>
--- a/round2/Axis.pptx
+++ b/round2/Axis.pptx
@@ -139,23 +139,23 @@
   <p:extLst>
     <p:ext uri="{521415D9-36F7-43E2-AB2F-B90AF26B5E84}">
       <p14:sectionLst xmlns:p14="http://schemas.microsoft.com/office/powerpoint/2010/main">
-        <p14:section name="Cover" id="{F97283D7-F421-4C62-BF26-01AD972183CE}">
+        <p14:section name="Cover" id="{BCC36DB7-B804-4A0E-823F-8CE4923E1CEA}">
           <p14:sldIdLst>
             <p14:sldId id="256"/>
           </p14:sldIdLst>
         </p14:section>
-        <p14:section name="The problem" id="{06C325B4-8EAC-4674-AC9D-8B27D054DCAE}">
+        <p14:section name="The problem" id="{B4AE20BB-9034-4E6E-8F67-8D0F02025850}">
           <p14:sldIdLst>
             <p14:sldId id="257"/>
             <p14:sldId id="258"/>
           </p14:sldIdLst>
         </p14:section>
-        <p14:section name="The answer" id="{32487D19-4432-4ED7-BF2A-DBD479AF98A6}">
+        <p14:section name="The answer" id="{8D566F6B-0025-498F-9483-AB0B3A4EA1C5}">
           <p14:sldIdLst>
             <p14:sldId id="259"/>
           </p14:sldIdLst>
         </p14:section>
-        <p14:section name="The five calls" id="{E10E7975-F12A-4E71-BF90-62D743E06665}">
+        <p14:section name="The five calls" id="{35499CFB-AF45-4277-B4BC-B738DF7B2B4B}">
           <p14:sldIdLst>
             <p14:sldId id="260"/>
             <p14:sldId id="261"/>
@@ -164,24 +164,24 @@
             <p14:sldId id="264"/>
           </p14:sldIdLst>
         </p14:section>
-        <p14:section name="Will it hold" id="{8A56E647-5397-4575-85B2-FD89F5F6AE48}">
+        <p14:section name="Will it hold" id="{6160854A-F5D2-4583-887B-EFF1C1FB7764}">
           <p14:sldIdLst>
             <p14:sldId id="265"/>
           </p14:sldIdLst>
         </p14:section>
-        <p14:section name="What next" id="{B025E062-29E1-49BA-BEA4-4EA273A27552}">
+        <p14:section name="What next" id="{F1AB1DD9-F96E-4BC1-9261-EA1FFA6A1B6C}">
           <p14:sldIdLst>
             <p14:sldId id="266"/>
             <p14:sldId id="267"/>
           </p14:sldIdLst>
         </p14:section>
-        <p14:section name="Us" id="{54184064-EAAB-464F-BA1A-CB40A565CAA3}">
+        <p14:section name="Us" id="{BE82FD12-45C9-4477-9010-40DE4ACE323C}">
           <p14:sldIdLst>
             <p14:sldId id="268"/>
             <p14:sldId id="269"/>
           </p14:sldIdLst>
         </p14:section>
-        <p14:section name="Close" id="{0217D62E-6241-4F06-8BE8-D87ACBC94D39}">
+        <p14:section name="Close" id="{4C57063A-78E2-4343-B017-A55E4647955D}">
           <p14:sldIdLst>
             <p14:sldId id="270"/>
           </p14:sldIdLst>
@@ -231,7 +231,7 @@
     </p:spTree>
     <p:extLst>
       <p:ext uri="{BB962C8B-B14F-4D97-AF65-F5344CB8AC3E}">
-        <p14:creationId xmlns:p14="http://schemas.microsoft.com/office/powerpoint/2010/main" val="3578137109"/>
+        <p14:creationId xmlns:p14="http://schemas.microsoft.com/office/powerpoint/2010/main" val="3931233745"/>
       </p:ext>
     </p:extLst>
   </p:cSld>
@@ -5621,7 +5621,7 @@
         </p:nvSpPr>
         <p:spPr>
           <a:xfrm>
-            <a:off x="457200" y="2475309"/>
+            <a:off x="457200" y="2532459"/>
             <a:ext cx="11277600" cy="9525"/>
           </a:xfrm>
           <a:prstGeom prst="rect">
@@ -5651,7 +5651,7 @@
         </p:nvSpPr>
         <p:spPr>
           <a:xfrm>
-            <a:off x="457200" y="1925104"/>
+            <a:off x="457200" y="1982254"/>
             <a:ext cx="2086746" cy="222885"/>
           </a:xfrm>
           <a:prstGeom prst="rect">
@@ -5696,7 +5696,7 @@
         </p:nvSpPr>
         <p:spPr>
           <a:xfrm>
-            <a:off x="457200" y="2147804"/>
+            <a:off x="457200" y="2204954"/>
             <a:ext cx="2363769" cy="180022"/>
           </a:xfrm>
           <a:prstGeom prst="rect">
@@ -5741,7 +5741,7 @@
         </p:nvSpPr>
         <p:spPr>
           <a:xfrm>
-            <a:off x="3390900" y="2176760"/>
+            <a:off x="3390900" y="2233910"/>
             <a:ext cx="5257800" cy="133350"/>
           </a:xfrm>
           <a:prstGeom prst="roundRect">
@@ -5773,7 +5773,7 @@
         </p:nvSpPr>
         <p:spPr>
           <a:xfrm rot="16200000">
-            <a:off x="4112865" y="1454795"/>
+            <a:off x="4112865" y="1511945"/>
             <a:ext cx="133350" cy="1577280"/>
           </a:xfrm>
           <a:prstGeom prst="round2SameRect">
@@ -5806,7 +5806,7 @@
         </p:nvSpPr>
         <p:spPr>
           <a:xfrm rot="5400000">
-            <a:off x="6294760" y="850181"/>
+            <a:off x="6294760" y="907331"/>
             <a:ext cx="133350" cy="2786509"/>
           </a:xfrm>
           <a:prstGeom prst="round2SameRect">
@@ -5847,7 +5847,7 @@
         </p:nvSpPr>
         <p:spPr>
           <a:xfrm>
-            <a:off x="4968180" y="2176760"/>
+            <a:off x="4968180" y="2233910"/>
             <a:ext cx="19050" cy="133350"/>
           </a:xfrm>
           <a:prstGeom prst="rect">
@@ -5877,7 +5877,7 @@
         </p:nvSpPr>
         <p:spPr>
           <a:xfrm>
-            <a:off x="4812655" y="1968734"/>
+            <a:off x="4812655" y="2025884"/>
             <a:ext cx="444014" cy="133350"/>
           </a:xfrm>
           <a:prstGeom prst="rect">
@@ -5922,7 +5922,7 @@
         </p:nvSpPr>
         <p:spPr>
           <a:xfrm>
-            <a:off x="7333059" y="1701463"/>
+            <a:off x="7333059" y="1758613"/>
             <a:ext cx="1008471" cy="381000"/>
           </a:xfrm>
           <a:prstGeom prst="rect">
@@ -5967,7 +5967,7 @@
         </p:nvSpPr>
         <p:spPr>
           <a:xfrm>
-            <a:off x="9182100" y="1827973"/>
+            <a:off x="9182100" y="1885123"/>
             <a:ext cx="1883396" cy="180022"/>
           </a:xfrm>
           <a:prstGeom prst="rect">
@@ -6021,7 +6021,7 @@
         </p:nvSpPr>
         <p:spPr>
           <a:xfrm>
-            <a:off x="9182100" y="2036481"/>
+            <a:off x="9182100" y="2093631"/>
             <a:ext cx="2102837" cy="180022"/>
           </a:xfrm>
           <a:prstGeom prst="rect">
@@ -6075,7 +6075,7 @@
         </p:nvSpPr>
         <p:spPr>
           <a:xfrm>
-            <a:off x="9182100" y="2244989"/>
+            <a:off x="9182100" y="2302139"/>
             <a:ext cx="1832440" cy="180022"/>
           </a:xfrm>
           <a:prstGeom prst="rect">
@@ -6129,7 +6129,7 @@
         </p:nvSpPr>
         <p:spPr>
           <a:xfrm>
-            <a:off x="457200" y="3132534"/>
+            <a:off x="457200" y="3189684"/>
             <a:ext cx="11277600" cy="9525"/>
           </a:xfrm>
           <a:prstGeom prst="rect">
@@ -6159,7 +6159,7 @@
         </p:nvSpPr>
         <p:spPr>
           <a:xfrm>
-            <a:off x="457200" y="2601956"/>
+            <a:off x="457200" y="2659106"/>
             <a:ext cx="1909111" cy="198120"/>
           </a:xfrm>
           <a:prstGeom prst="rect">
@@ -6204,7 +6204,7 @@
         </p:nvSpPr>
         <p:spPr>
           <a:xfrm>
-            <a:off x="457200" y="2805476"/>
+            <a:off x="457200" y="2862626"/>
             <a:ext cx="2263750" cy="180022"/>
           </a:xfrm>
           <a:prstGeom prst="rect">
@@ -6249,7 +6249,7 @@
         </p:nvSpPr>
         <p:spPr>
           <a:xfrm>
-            <a:off x="3390900" y="2846784"/>
+            <a:off x="3390900" y="2903934"/>
             <a:ext cx="5257800" cy="133350"/>
           </a:xfrm>
           <a:prstGeom prst="roundRect">
@@ -6281,7 +6281,7 @@
         </p:nvSpPr>
         <p:spPr>
           <a:xfrm rot="16200000">
-            <a:off x="4165402" y="2072283"/>
+            <a:off x="4165402" y="2129433"/>
             <a:ext cx="133350" cy="1682353"/>
           </a:xfrm>
           <a:prstGeom prst="round2SameRect">
@@ -6314,7 +6314,7 @@
         </p:nvSpPr>
         <p:spPr>
           <a:xfrm rot="5400000">
-            <a:off x="6662738" y="1257300"/>
+            <a:off x="6662738" y="1314450"/>
             <a:ext cx="133350" cy="3312319"/>
           </a:xfrm>
           <a:prstGeom prst="round2SameRect">
@@ -6355,7 +6355,7 @@
         </p:nvSpPr>
         <p:spPr>
           <a:xfrm>
-            <a:off x="5073253" y="2846784"/>
+            <a:off x="5073253" y="2903934"/>
             <a:ext cx="19050" cy="133350"/>
           </a:xfrm>
           <a:prstGeom prst="rect">
@@ -6385,7 +6385,7 @@
         </p:nvSpPr>
         <p:spPr>
           <a:xfrm>
-            <a:off x="4926062" y="2638758"/>
+            <a:off x="4926062" y="2695908"/>
             <a:ext cx="426345" cy="133350"/>
           </a:xfrm>
           <a:prstGeom prst="rect">
@@ -6430,7 +6430,7 @@
         </p:nvSpPr>
         <p:spPr>
           <a:xfrm>
-            <a:off x="8174385" y="2573417"/>
+            <a:off x="8174385" y="2630567"/>
             <a:ext cx="562332" cy="190500"/>
           </a:xfrm>
           <a:prstGeom prst="rect">
@@ -6475,7 +6475,7 @@
         </p:nvSpPr>
         <p:spPr>
           <a:xfrm>
-            <a:off x="9182100" y="2602176"/>
+            <a:off x="9182100" y="2659326"/>
             <a:ext cx="2102837" cy="180022"/>
           </a:xfrm>
           <a:prstGeom prst="rect">
@@ -6529,7 +6529,7 @@
         </p:nvSpPr>
         <p:spPr>
           <a:xfrm>
-            <a:off x="9182100" y="2810685"/>
+            <a:off x="9182100" y="2867835"/>
             <a:ext cx="2143223" cy="180022"/>
           </a:xfrm>
           <a:prstGeom prst="rect">
@@ -6583,7 +6583,7 @@
         </p:nvSpPr>
         <p:spPr>
           <a:xfrm>
-            <a:off x="457200" y="3789759"/>
+            <a:off x="457200" y="3846909"/>
             <a:ext cx="11277600" cy="9525"/>
           </a:xfrm>
           <a:prstGeom prst="rect">
@@ -6613,7 +6613,7 @@
         </p:nvSpPr>
         <p:spPr>
           <a:xfrm>
-            <a:off x="457200" y="3259181"/>
+            <a:off x="457200" y="3316331"/>
             <a:ext cx="2194968" cy="198120"/>
           </a:xfrm>
           <a:prstGeom prst="rect">
@@ -6658,7 +6658,7 @@
         </p:nvSpPr>
         <p:spPr>
           <a:xfrm>
-            <a:off x="457200" y="3462701"/>
+            <a:off x="457200" y="3519851"/>
             <a:ext cx="2427345" cy="180022"/>
           </a:xfrm>
           <a:prstGeom prst="rect">
@@ -6703,7 +6703,7 @@
         </p:nvSpPr>
         <p:spPr>
           <a:xfrm>
-            <a:off x="3390900" y="3504009"/>
+            <a:off x="3390900" y="3561159"/>
             <a:ext cx="5257800" cy="133350"/>
           </a:xfrm>
           <a:prstGeom prst="roundRect">
@@ -6735,7 +6735,7 @@
         </p:nvSpPr>
         <p:spPr>
           <a:xfrm rot="16200000">
-            <a:off x="4060254" y="2834655"/>
+            <a:off x="4060254" y="2891805"/>
             <a:ext cx="133350" cy="1472059"/>
           </a:xfrm>
           <a:prstGeom prst="round2SameRect">
@@ -6768,7 +6768,7 @@
         </p:nvSpPr>
         <p:spPr>
           <a:xfrm rot="5400000">
-            <a:off x="6478712" y="1888257"/>
+            <a:off x="6478712" y="1945407"/>
             <a:ext cx="133350" cy="3364855"/>
           </a:xfrm>
           <a:prstGeom prst="round2SameRect">
@@ -6809,7 +6809,7 @@
         </p:nvSpPr>
         <p:spPr>
           <a:xfrm>
-            <a:off x="4862959" y="3504009"/>
+            <a:off x="4862959" y="3561159"/>
             <a:ext cx="19050" cy="133350"/>
           </a:xfrm>
           <a:prstGeom prst="rect">
@@ -6839,7 +6839,7 @@
         </p:nvSpPr>
         <p:spPr>
           <a:xfrm>
-            <a:off x="4714503" y="3295983"/>
+            <a:off x="4714503" y="3353133"/>
             <a:ext cx="429027" cy="133350"/>
           </a:xfrm>
           <a:prstGeom prst="rect">
@@ -6884,7 +6884,7 @@
         </p:nvSpPr>
         <p:spPr>
           <a:xfrm>
-            <a:off x="8018338" y="3230642"/>
+            <a:off x="8018338" y="3287792"/>
             <a:ext cx="558704" cy="190500"/>
           </a:xfrm>
           <a:prstGeom prst="rect">
@@ -6929,7 +6929,7 @@
         </p:nvSpPr>
         <p:spPr>
           <a:xfrm>
-            <a:off x="9182100" y="3259401"/>
+            <a:off x="9182100" y="3316551"/>
             <a:ext cx="2215634" cy="180022"/>
           </a:xfrm>
           <a:prstGeom prst="rect">
@@ -6983,7 +6983,7 @@
         </p:nvSpPr>
         <p:spPr>
           <a:xfrm>
-            <a:off x="9182100" y="3467910"/>
+            <a:off x="9182100" y="3525060"/>
             <a:ext cx="2165309" cy="180022"/>
           </a:xfrm>
           <a:prstGeom prst="rect">
@@ -7037,7 +7037,7 @@
         </p:nvSpPr>
         <p:spPr>
           <a:xfrm>
-            <a:off x="457200" y="4446984"/>
+            <a:off x="457200" y="4504134"/>
             <a:ext cx="11277600" cy="9525"/>
           </a:xfrm>
           <a:prstGeom prst="rect">
@@ -7067,7 +7067,7 @@
         </p:nvSpPr>
         <p:spPr>
           <a:xfrm>
-            <a:off x="457200" y="3916406"/>
+            <a:off x="457200" y="3973556"/>
             <a:ext cx="1530965" cy="198120"/>
           </a:xfrm>
           <a:prstGeom prst="rect">
@@ -7112,7 +7112,7 @@
         </p:nvSpPr>
         <p:spPr>
           <a:xfrm>
-            <a:off x="457200" y="4119926"/>
+            <a:off x="457200" y="4177076"/>
             <a:ext cx="1860994" cy="180022"/>
           </a:xfrm>
           <a:prstGeom prst="rect">
@@ -7157,7 +7157,7 @@
         </p:nvSpPr>
         <p:spPr>
           <a:xfrm>
-            <a:off x="3390900" y="4161234"/>
+            <a:off x="3390900" y="4218384"/>
             <a:ext cx="5257800" cy="133350"/>
           </a:xfrm>
           <a:prstGeom prst="roundRect">
@@ -7189,7 +7189,7 @@
         </p:nvSpPr>
         <p:spPr>
           <a:xfrm rot="16200000">
-            <a:off x="4927848" y="2624286"/>
+            <a:off x="4927848" y="2681436"/>
             <a:ext cx="133350" cy="3207246"/>
           </a:xfrm>
           <a:prstGeom prst="round2SameRect">
@@ -7222,7 +7222,7 @@
         </p:nvSpPr>
         <p:spPr>
           <a:xfrm rot="5400000">
-            <a:off x="7530405" y="3228975"/>
+            <a:off x="7530405" y="3286125"/>
             <a:ext cx="133350" cy="1997869"/>
           </a:xfrm>
           <a:prstGeom prst="round2SameRect">
@@ -7263,7 +7263,7 @@
         </p:nvSpPr>
         <p:spPr>
           <a:xfrm>
-            <a:off x="6598146" y="4161234"/>
+            <a:off x="6598146" y="4218384"/>
             <a:ext cx="19050" cy="133350"/>
           </a:xfrm>
           <a:prstGeom prst="rect">
@@ -7293,7 +7293,7 @@
         </p:nvSpPr>
         <p:spPr>
           <a:xfrm>
-            <a:off x="6466136" y="3953208"/>
+            <a:off x="6466136" y="4010358"/>
             <a:ext cx="394162" cy="133350"/>
           </a:xfrm>
           <a:prstGeom prst="rect">
@@ -7338,7 +7338,7 @@
         </p:nvSpPr>
         <p:spPr>
           <a:xfrm>
-            <a:off x="8385944" y="3887867"/>
+            <a:off x="8385944" y="3945017"/>
             <a:ext cx="559650" cy="190500"/>
           </a:xfrm>
           <a:prstGeom prst="rect">
@@ -7383,7 +7383,7 @@
         </p:nvSpPr>
         <p:spPr>
           <a:xfrm>
-            <a:off x="9182100" y="4020806"/>
+            <a:off x="9182100" y="4077956"/>
             <a:ext cx="1463918" cy="180022"/>
           </a:xfrm>
           <a:prstGeom prst="rect">
@@ -7437,7 +7437,7 @@
         </p:nvSpPr>
         <p:spPr>
           <a:xfrm>
-            <a:off x="3390900" y="4505658"/>
+            <a:off x="3390900" y="4562808"/>
             <a:ext cx="355512" cy="133350"/>
           </a:xfrm>
           <a:prstGeom prst="rect">
@@ -7482,7 +7482,7 @@
         </p:nvSpPr>
         <p:spPr>
           <a:xfrm>
-            <a:off x="5864944" y="4505658"/>
+            <a:off x="5864944" y="4562808"/>
             <a:ext cx="442594" cy="133350"/>
           </a:xfrm>
           <a:prstGeom prst="rect">
@@ -7527,7 +7527,7 @@
         </p:nvSpPr>
         <p:spPr>
           <a:xfrm>
-            <a:off x="8274100" y="4505658"/>
+            <a:off x="8274100" y="4562808"/>
             <a:ext cx="511376" cy="133350"/>
           </a:xfrm>
           <a:prstGeom prst="rect">
@@ -7572,7 +7572,7 @@
         </p:nvSpPr>
         <p:spPr>
           <a:xfrm>
-            <a:off x="457200" y="4745688"/>
+            <a:off x="457200" y="4802838"/>
             <a:ext cx="8587157" cy="186690"/>
           </a:xfrm>
           <a:prstGeom prst="rect">
@@ -36578,7 +36578,7 @@
         </p:nvSpPr>
         <p:spPr>
           <a:xfrm>
-            <a:off x="2005274" y="2897928"/>
+            <a:off x="2181933" y="2910132"/>
             <a:ext cx="935903" cy="320010"/>
           </a:xfrm>
           <a:prstGeom prst="rect">
@@ -38213,7 +38213,7 @@
         </p:nvSpPr>
         <p:spPr>
           <a:xfrm>
-            <a:off x="9299633" y="5063466"/>
+            <a:off x="9726567" y="5063466"/>
             <a:ext cx="853869" cy="166688"/>
           </a:xfrm>
           <a:prstGeom prst="rect">
@@ -38227,7 +38227,7 @@
           </a:bodyPr>
           <a:lstStyle/>
           <a:p>
-            <a:pPr algn="r">
+            <a:pPr algn="ctr">
               <a:lnSpc>
                 <a:spcPts val="1312"/>
               </a:lnSpc>
@@ -38258,7 +38258,7 @@
         </p:nvSpPr>
         <p:spPr>
           <a:xfrm>
-            <a:off x="9682037" y="4896779"/>
+            <a:off x="9917769" y="4896779"/>
             <a:ext cx="471464" cy="166688"/>
           </a:xfrm>
           <a:prstGeom prst="rect">
@@ -38272,7 +38272,7 @@
           </a:bodyPr>
           <a:lstStyle/>
           <a:p>
-            <a:pPr algn="r">
+            <a:pPr algn="ctr">
               <a:lnSpc>
                 <a:spcPts val="1312"/>
               </a:lnSpc>
@@ -45787,7 +45787,7 @@
         </p:nvSpPr>
         <p:spPr>
           <a:xfrm>
-            <a:off x="3450729" y="2294072"/>
+            <a:off x="3152924" y="2294072"/>
             <a:ext cx="810643" cy="133350"/>
           </a:xfrm>
           <a:prstGeom prst="rect">

</xml_diff>

<commit_message>
PowerPoint: no transition between slides, except Morph into slides 5 to 9
Pete didn't like the fade between slides. Every slide now changes with no
transition; only the five call slides keep Morph (the house carried from
slide 4 into each call's corner). Clicks unchanged. Checked through
PowerPoint: transitions none on 1-4 and 10-15, Morph on 5-9, in both files.

Co-Authored-By: Claude Opus 5.5 (1M context) <noreply@anthropic.com>
</commit_message>
<xml_diff>
--- a/round2/Axis.pptx
+++ b/round2/Axis.pptx
@@ -139,23 +139,23 @@
   <p:extLst>
     <p:ext uri="{521415D9-36F7-43E2-AB2F-B90AF26B5E84}">
       <p14:sectionLst xmlns:p14="http://schemas.microsoft.com/office/powerpoint/2010/main">
-        <p14:section name="Cover" id="{A51F3274-C6D8-4CC7-B1C8-7879F99C7AEA}">
+        <p14:section name="Cover" id="{9321C5E2-89CE-4CFC-A994-CC066B61392A}">
           <p14:sldIdLst>
             <p14:sldId id="256"/>
           </p14:sldIdLst>
         </p14:section>
-        <p14:section name="The problem" id="{24F0F80F-E5B0-4FA9-95EB-7CD8D059BCBA}">
+        <p14:section name="The problem" id="{D4F771E1-4EA3-4336-B6DA-7DB755AB7A46}">
           <p14:sldIdLst>
             <p14:sldId id="257"/>
             <p14:sldId id="258"/>
           </p14:sldIdLst>
         </p14:section>
-        <p14:section name="The answer" id="{DAB36994-4E1C-4ADD-BDCB-67B54966F9F2}">
+        <p14:section name="The answer" id="{03AAD265-7E18-4518-9306-EC22F2B0359D}">
           <p14:sldIdLst>
             <p14:sldId id="259"/>
           </p14:sldIdLst>
         </p14:section>
-        <p14:section name="The five calls" id="{D6132812-9CF1-4AA1-AE5B-9878FCEB414E}">
+        <p14:section name="The five calls" id="{AA0E7B54-B786-4B2E-966D-760C1E45653E}">
           <p14:sldIdLst>
             <p14:sldId id="260"/>
             <p14:sldId id="261"/>
@@ -164,24 +164,24 @@
             <p14:sldId id="264"/>
           </p14:sldIdLst>
         </p14:section>
-        <p14:section name="Will it hold" id="{3E582B87-30B0-4BB5-AF3E-202879F717A1}">
+        <p14:section name="Will it hold" id="{6F0AFBA2-C7D9-4128-9836-D4285419D073}">
           <p14:sldIdLst>
             <p14:sldId id="265"/>
           </p14:sldIdLst>
         </p14:section>
-        <p14:section name="What next" id="{DB546855-8D15-4EC6-B059-4B7EB544973A}">
+        <p14:section name="What next" id="{1E6BC120-FE7A-403E-A384-81A1DA6F56F2}">
           <p14:sldIdLst>
             <p14:sldId id="266"/>
             <p14:sldId id="267"/>
           </p14:sldIdLst>
         </p14:section>
-        <p14:section name="Us" id="{B0C18B8A-A580-4F94-8368-057315AB9B0E}">
+        <p14:section name="Us" id="{5C9F4454-BB95-4FD6-87CA-C615C350A411}">
           <p14:sldIdLst>
             <p14:sldId id="268"/>
             <p14:sldId id="269"/>
           </p14:sldIdLst>
         </p14:section>
-        <p14:section name="Close" id="{FDFBEA0C-6C7A-447F-B8EF-6DB218777EB7}">
+        <p14:section name="Close" id="{FA6F6607-0C42-4432-91F0-0BF36BE60521}">
           <p14:sldIdLst>
             <p14:sldId id="270"/>
           </p14:sldIdLst>
@@ -231,7 +231,7 @@
     </p:spTree>
     <p:extLst>
       <p:ext uri="{BB962C8B-B14F-4D97-AF65-F5344CB8AC3E}">
-        <p14:creationId xmlns:p14="http://schemas.microsoft.com/office/powerpoint/2010/main" val="192233609"/>
+        <p14:creationId xmlns:p14="http://schemas.microsoft.com/office/powerpoint/2010/main" val="1750843937"/>
       </p:ext>
     </p:extLst>
   </p:cSld>
@@ -5182,9 +5182,6 @@
   <p:clrMapOvr>
     <a:masterClrMapping/>
   </p:clrMapOvr>
-  <p:transition>
-    <p:fade/>
-  </p:transition>
 </p:sld>
 </file>
 
@@ -8768,9 +8765,6 @@
   <p:clrMapOvr>
     <a:masterClrMapping/>
   </p:clrMapOvr>
-  <p:transition>
-    <p:fade/>
-  </p:transition>
 </p:sld>
 </file>
 
@@ -12362,9 +12356,6 @@
   <p:clrMapOvr>
     <a:masterClrMapping/>
   </p:clrMapOvr>
-  <p:transition>
-    <p:fade/>
-  </p:transition>
 </p:sld>
 </file>
 
@@ -15485,9 +15476,6 @@
   <p:clrMapOvr>
     <a:masterClrMapping/>
   </p:clrMapOvr>
-  <p:transition>
-    <p:fade/>
-  </p:transition>
 </p:sld>
 </file>
 
@@ -17659,9 +17647,6 @@
   <p:clrMapOvr>
     <a:masterClrMapping/>
   </p:clrMapOvr>
-  <p:transition>
-    <p:fade/>
-  </p:transition>
 </p:sld>
 </file>
 
@@ -20472,9 +20457,6 @@
   <p:clrMapOvr>
     <a:masterClrMapping/>
   </p:clrMapOvr>
-  <p:transition>
-    <p:fade/>
-  </p:transition>
 </p:sld>
 </file>
 
@@ -22049,9 +22031,6 @@
   <p:clrMapOvr>
     <a:masterClrMapping/>
   </p:clrMapOvr>
-  <p:transition>
-    <p:fade/>
-  </p:transition>
 </p:sld>
 </file>
 
@@ -25374,9 +25353,6 @@
   <p:clrMapOvr>
     <a:masterClrMapping/>
   </p:clrMapOvr>
-  <p:transition>
-    <p:fade/>
-  </p:transition>
 </p:sld>
 </file>
 
@@ -28057,9 +28033,6 @@
   <p:clrMapOvr>
     <a:masterClrMapping/>
   </p:clrMapOvr>
-  <p:transition>
-    <p:fade/>
-  </p:transition>
 </p:sld>
 </file>
 
@@ -29926,9 +29899,6 @@
   <p:clrMapOvr>
     <a:masterClrMapping/>
   </p:clrMapOvr>
-  <p:transition>
-    <p:fade/>
-  </p:transition>
 </p:sld>
 </file>
 

</xml_diff>

<commit_message>
Axis.pptx rebuilt: slide 2's new speaker notes
Co-Authored-By: Claude Opus 5.5 (1M context) <noreply@anthropic.com>
</commit_message>
<xml_diff>
--- a/round2/Axis.pptx
+++ b/round2/Axis.pptx
@@ -139,23 +139,23 @@
   <p:extLst>
     <p:ext uri="{521415D9-36F7-43E2-AB2F-B90AF26B5E84}">
       <p14:sectionLst xmlns:p14="http://schemas.microsoft.com/office/powerpoint/2010/main">
-        <p14:section name="Cover" id="{9321C5E2-89CE-4CFC-A994-CC066B61392A}">
+        <p14:section name="Cover" id="{9CE0B77E-E670-4EA4-82CE-BD1F4EF43F5B}">
           <p14:sldIdLst>
             <p14:sldId id="256"/>
           </p14:sldIdLst>
         </p14:section>
-        <p14:section name="The problem" id="{D4F771E1-4EA3-4336-B6DA-7DB755AB7A46}">
+        <p14:section name="The problem" id="{C058EAEE-E277-48D0-8B29-171270A3544B}">
           <p14:sldIdLst>
             <p14:sldId id="257"/>
             <p14:sldId id="258"/>
           </p14:sldIdLst>
         </p14:section>
-        <p14:section name="The answer" id="{03AAD265-7E18-4518-9306-EC22F2B0359D}">
+        <p14:section name="The answer" id="{99BF1773-0216-4DBC-A6CB-F876E17578ED}">
           <p14:sldIdLst>
             <p14:sldId id="259"/>
           </p14:sldIdLst>
         </p14:section>
-        <p14:section name="The five calls" id="{AA0E7B54-B786-4B2E-966D-760C1E45653E}">
+        <p14:section name="The five calls" id="{6136F35F-6C78-4486-ABCB-B043699B5157}">
           <p14:sldIdLst>
             <p14:sldId id="260"/>
             <p14:sldId id="261"/>
@@ -164,24 +164,24 @@
             <p14:sldId id="264"/>
           </p14:sldIdLst>
         </p14:section>
-        <p14:section name="Will it hold" id="{6F0AFBA2-C7D9-4128-9836-D4285419D073}">
+        <p14:section name="Will it hold" id="{9F5277C4-8072-45CB-8EB1-466EF69B2FD7}">
           <p14:sldIdLst>
             <p14:sldId id="265"/>
           </p14:sldIdLst>
         </p14:section>
-        <p14:section name="What next" id="{1E6BC120-FE7A-403E-A384-81A1DA6F56F2}">
+        <p14:section name="What next" id="{08A1CB09-CB48-4148-B684-836D250B32B6}">
           <p14:sldIdLst>
             <p14:sldId id="266"/>
             <p14:sldId id="267"/>
           </p14:sldIdLst>
         </p14:section>
-        <p14:section name="Us" id="{5C9F4454-BB95-4FD6-87CA-C615C350A411}">
+        <p14:section name="Us" id="{BD68B797-A3C2-4D76-9CF9-C818874E22D4}">
           <p14:sldIdLst>
             <p14:sldId id="268"/>
             <p14:sldId id="269"/>
           </p14:sldIdLst>
         </p14:section>
-        <p14:section name="Close" id="{FA6F6607-0C42-4432-91F0-0BF36BE60521}">
+        <p14:section name="Close" id="{39D44F7F-4E51-449A-B236-98988BD02B3A}">
           <p14:sldIdLst>
             <p14:sldId id="270"/>
           </p14:sldIdLst>
@@ -231,7 +231,7 @@
     </p:spTree>
     <p:extLst>
       <p:ext uri="{BB962C8B-B14F-4D97-AF65-F5344CB8AC3E}">
-        <p14:creationId xmlns:p14="http://schemas.microsoft.com/office/powerpoint/2010/main" val="1750843937"/>
+        <p14:creationId xmlns:p14="http://schemas.microsoft.com/office/powerpoint/2010/main" val="4002544855"/>
       </p:ext>
     </p:extLst>
   </p:cSld>
@@ -901,7 +901,7 @@
           <a:lstStyle/>
           <a:p>
             <a:r>
-              <a:t>Pete: Meet the Wongs. Adrian, 54, wants his capital, retirement and health protected. Carmen, 49, runs a business and wants money that reflects her values. Ryan, 24, holds crypto. Chloe, 16, starts university in 2028. On paper, they're secure: HK$24.4 million. The parents want to retire at 65 and 62, on HK$780K a year. But will it last to Carmen's 89? We tested it in 10,000 futures.</a:t>
+              <a:t>Pete: Meet the Wongs. On paper, they're secure: HK$24.4 million, but most of it is their home and Carmen's business. And it must last forty years. Ryan, 24, holds crypto and wants his own plan. Chloe, 16, may study here or abroad. Adrian, 54, wants capital and health protected; he retires at 65. Carmen, 49, wants money that reflects her values; she retires at 62. Then 27 years on HK$780K a year. Will it last to Carmen's 89? We tested it in 10,000 futures.</a:t>
             </a:r>
           </a:p>
         </p:txBody>

</xml_diff>

<commit_message>
Slide 7: "they stay in their home", not "keep the home"
Pete asked whether the plan's reverse mortgage isn't also selling the home.
On the money it is: it spends the home's value, and the inheritance
(HK$7.7M) is already counted after the loan. What differs is the parents'
lives and the timing: chosen at 65, together, and they never leave (HKMC:
owners for life; heirs may repay and keep the flat, owe no shortfall)
versus a forced move at about 83, usually with Carmen alone. So the title,
the bar, the chart label ("Their home, for life") and the script now say
they stay in their home, and the notes carry the answer for Q&A. Plan,
talk outline, script, frames and both PowerPoint files updated.

Co-Authored-By: Claude Opus 5.5 (1M context) <noreply@anthropic.com>
</commit_message>
<xml_diff>
--- a/round2/Axis.pptx
+++ b/round2/Axis.pptx
@@ -139,23 +139,23 @@
   <p:extLst>
     <p:ext uri="{521415D9-36F7-43E2-AB2F-B90AF26B5E84}">
       <p14:sectionLst xmlns:p14="http://schemas.microsoft.com/office/powerpoint/2010/main">
-        <p14:section name="Cover" id="{9CE0B77E-E670-4EA4-82CE-BD1F4EF43F5B}">
+        <p14:section name="Cover" id="{302C5F62-4522-41A4-8FF0-BDBB2A78EBEE}">
           <p14:sldIdLst>
             <p14:sldId id="256"/>
           </p14:sldIdLst>
         </p14:section>
-        <p14:section name="The problem" id="{C058EAEE-E277-48D0-8B29-171270A3544B}">
+        <p14:section name="The problem" id="{AF7942FC-9731-4212-92C8-29B2BAD8FDC1}">
           <p14:sldIdLst>
             <p14:sldId id="257"/>
             <p14:sldId id="258"/>
           </p14:sldIdLst>
         </p14:section>
-        <p14:section name="The answer" id="{99BF1773-0216-4DBC-A6CB-F876E17578ED}">
+        <p14:section name="The answer" id="{D2654892-0012-490F-8990-2F8C5238DEB4}">
           <p14:sldIdLst>
             <p14:sldId id="259"/>
           </p14:sldIdLst>
         </p14:section>
-        <p14:section name="The five calls" id="{6136F35F-6C78-4486-ABCB-B043699B5157}">
+        <p14:section name="The five calls" id="{E5C06E21-CC49-4B03-A6F0-86EB970EA179}">
           <p14:sldIdLst>
             <p14:sldId id="260"/>
             <p14:sldId id="261"/>
@@ -164,24 +164,24 @@
             <p14:sldId id="264"/>
           </p14:sldIdLst>
         </p14:section>
-        <p14:section name="Will it hold" id="{9F5277C4-8072-45CB-8EB1-466EF69B2FD7}">
+        <p14:section name="Will it hold" id="{B6B10935-F245-4DB5-8B41-8B0E17B545D4}">
           <p14:sldIdLst>
             <p14:sldId id="265"/>
           </p14:sldIdLst>
         </p14:section>
-        <p14:section name="What next" id="{08A1CB09-CB48-4148-B684-836D250B32B6}">
+        <p14:section name="What next" id="{8AD3AA04-64B1-4461-A53B-AB28A58E1108}">
           <p14:sldIdLst>
             <p14:sldId id="266"/>
             <p14:sldId id="267"/>
           </p14:sldIdLst>
         </p14:section>
-        <p14:section name="Us" id="{BD68B797-A3C2-4D76-9CF9-C818874E22D4}">
+        <p14:section name="Us" id="{9933B526-C076-46EA-8662-A51B6775E76D}">
           <p14:sldIdLst>
             <p14:sldId id="268"/>
             <p14:sldId id="269"/>
           </p14:sldIdLst>
         </p14:section>
-        <p14:section name="Close" id="{39D44F7F-4E51-449A-B236-98988BD02B3A}">
+        <p14:section name="Close" id="{DCBDB06B-A024-469C-BC23-4040E7B477C7}">
           <p14:sldIdLst>
             <p14:sldId id="270"/>
           </p14:sldIdLst>
@@ -231,7 +231,7 @@
     </p:spTree>
     <p:extLst>
       <p:ext uri="{BB962C8B-B14F-4D97-AF65-F5344CB8AC3E}">
-        <p14:creationId xmlns:p14="http://schemas.microsoft.com/office/powerpoint/2010/main" val="4002544855"/>
+        <p14:creationId xmlns:p14="http://schemas.microsoft.com/office/powerpoint/2010/main" val="1643087477"/>
       </p:ext>
     </p:extLst>
   </p:cSld>
@@ -1251,7 +1251,7 @@
           <a:lstStyle/>
           <a:p>
             <a:r>
-              <a:t>Fahtai: Call three: the cost the budget ignores. Kept on Flexi for life, medical premiums climb to HK$375K a year, close to half the budget. So at Adrian's 75 they review the tier: the Standard plan costs a third as much, with lower limits. And from 2039, two spending rules for the bad years; essentials are never cut. Remember that future? Now the money lasts to 89, and the home stays theirs: 97% with the review, almost every future with the rules. Win.</a:t>
+              <a:t>Fahtai: Call three: the cost the budget ignores. Kept on Flexi for life, medical premiums climb to HK$375K a year, close to half the budget. So at Adrian's 75 they review the tier: the Standard plan costs a third as much, with lower limits. And from 2039, two spending rules for the bad years; essentials are never cut. Remember that future? Now the money lasts to 89, and they stay in their home: 97% with the review, almost every future with the rules. Win.</a:t>
             </a:r>
           </a:p>
         </p:txBody>
@@ -35959,7 +35959,7 @@
 
 <file path=ppt/slides/slide7.xml><?xml version="1.0" encoding="utf-8"?>
 <p:sld xmlns:a="http://schemas.openxmlformats.org/drawingml/2006/main" xmlns:r="http://schemas.openxmlformats.org/officeDocument/2006/relationships" xmlns:p="http://schemas.openxmlformats.org/presentationml/2006/main">
-  <p:cSld name="Fix the cost the budget ignores: in that same future, the money now lasts to 89 and the home stays theirs">
+  <p:cSld name="Fix the cost the budget ignores: in that same future, the money now lasts to 89 and they stay in their home">
     <p:spTree>
       <p:nvGrpSpPr>
         <p:cNvPr id="1" name=""/>
@@ -36088,7 +36088,7 @@
         <p:spPr>
           <a:xfrm>
             <a:off x="638175" y="529852"/>
-            <a:ext cx="7193524" cy="640699"/>
+            <a:ext cx="7353648" cy="640699"/>
           </a:xfrm>
           <a:prstGeom prst="rect">
             <a:avLst/>
@@ -36141,7 +36141,7 @@
                 </a:solidFill>
                 <a:latin typeface="Plus Jakarta Sans"/>
               </a:rPr>
-              <a:t>the money now lasts to 89 and the home stays theirs</a:t>
+              <a:t>the money now lasts to 89 and they stay in their home</a:t>
             </a:r>
           </a:p>
         </p:txBody>
@@ -38446,8 +38446,8 @@
         </p:nvSpPr>
         <p:spPr>
           <a:xfrm>
-            <a:off x="1405981" y="5984558"/>
-            <a:ext cx="9379890" cy="247650"/>
+            <a:off x="1282925" y="5984558"/>
+            <a:ext cx="9626150" cy="247650"/>
           </a:xfrm>
           <a:prstGeom prst="rect">
             <a:avLst/>
@@ -38478,7 +38478,7 @@
                 </a:solidFill>
                 <a:latin typeface="Plus Jakarta Sans SemiBold"/>
               </a:rPr>
-              <a:t>Will it last? In almost every future: they retire on time, keep the way they live, and keep the home.</a:t>
+              <a:t>Will it last? In almost every future: they retire on time, keep the way they live, and stay in their home.</a:t>
             </a:r>
           </a:p>
         </p:txBody>
@@ -39004,14 +39004,14 @@
       </p:sp>
       <p:sp>
         <p:nvSpPr>
-          <p:cNvPr id="71" name="!!T The home: still theirs"/>
+          <p:cNvPr id="71" name="!!T Their home, for life"/>
           <p:cNvSpPr txBox="1"/>
           <p:nvPr/>
         </p:nvSpPr>
         <p:spPr>
           <a:xfrm>
             <a:off x="5918150" y="4365998"/>
-            <a:ext cx="1492472" cy="173355"/>
+            <a:ext cx="1364531" cy="173355"/>
           </a:xfrm>
           <a:prstGeom prst="rect">
             <a:avLst/>
@@ -39042,7 +39042,7 @@
                 </a:solidFill>
                 <a:latin typeface="Plus Jakarta Sans SemiBold"/>
               </a:rPr>
-              <a:t>The home: still theirs</a:t>
+              <a:t>Their home, for life</a:t>
             </a:r>
           </a:p>
         </p:txBody>

</xml_diff>